<commit_message>
Bold inline code; lower-case steam_data_stories in Setting Up; rebuild slides
</commit_message>
<xml_diff>
--- a/slides/00_Setting_Up.pptx
+++ b/slides/00_Setting_Up.pptx
@@ -135,7 +135,7 @@
   <p:extLst>
     <p:ext uri="{521415D9-36F7-43E2-AB2F-B90AF26B5E84}">
       <p14:sectionLst xmlns:p14="http://schemas.microsoft.com/office/powerpoint/2010/main">
-        <p14:section name="Introduction" id="{10d0ffff-316e-e844-d0f9-009953fae3ed}">
+        <p14:section name="Introduction" id="{37c874e3-0558-fd80-2ed3-450bcbbc7fae}">
           <p14:sldIdLst>
             <p14:sldId id="256"/>
             <p14:sldId id="257"/>
@@ -143,20 +143,20 @@
             <p14:sldId id="259"/>
           </p14:sldIdLst>
         </p14:section>
-        <p14:section name="Install Python and VS Code" id="{0106ff28-2a34-9b35-f739-5a0a98cb3738}">
+        <p14:section name="Install Python and VS Code" id="{f11fa4f8-1625-e81f-cdad-444b6e0cca74}">
           <p14:sldIdLst>
             <p14:sldId id="260"/>
             <p14:sldId id="261"/>
             <p14:sldId id="262"/>
           </p14:sldIdLst>
         </p14:section>
-        <p14:section name="Create the project folder" id="{8182e852-898d-2d28-2110-6e7cf294179d}">
+        <p14:section name="Create the project folder" id="{184d769b-71b2-caa6-02f8-84728769b4d0}">
           <p14:sldIdLst>
             <p14:sldId id="263"/>
             <p14:sldId id="264"/>
           </p14:sldIdLst>
         </p14:section>
-        <p14:section name="Create a virtual environment" id="{0c83215f-295d-1cd3-0e4d-1dced1084929}">
+        <p14:section name="Create a virtual environment" id="{419cf817-f63b-6d09-ae39-db8d31021572}">
           <p14:sldIdLst>
             <p14:sldId id="265"/>
             <p14:sldId id="266"/>
@@ -165,7 +165,7 @@
             <p14:sldId id="269"/>
           </p14:sldIdLst>
         </p14:section>
-        <p14:section name="Install the libraries" id="{39d11750-1389-4180-19c9-c95bb5ee0391}">
+        <p14:section name="Install the libraries" id="{1d5a7803-d09c-812f-a610-0f10260c4a8d}">
           <p14:sldIdLst>
             <p14:sldId id="270"/>
             <p14:sldId id="271"/>
@@ -173,7 +173,7 @@
             <p14:sldId id="273"/>
           </p14:sldIdLst>
         </p14:section>
-        <p14:section name="Download the data" id="{8488c883-a7bb-ab0f-975d-b33bc7ccf0b0}">
+        <p14:section name="Download the data" id="{2a260fdc-f68e-0adf-c0e6-57f86c08eab2}">
           <p14:sldIdLst>
             <p14:sldId id="274"/>
             <p14:sldId id="275"/>
@@ -182,7 +182,7 @@
             <p14:sldId id="278"/>
           </p14:sldIdLst>
         </p14:section>
-        <p14:section name="Open our first notebook" id="{4123fb9f-2d9a-15eb-51a9-b5bc470a84d7}">
+        <p14:section name="Open our first notebook" id="{809eed68-3fbf-265e-3c33-ca3f5edce3d3}">
           <p14:sldIdLst>
             <p14:sldId id="279"/>
             <p14:sldId id="280"/>
@@ -191,7 +191,7 @@
             <p14:sldId id="283"/>
           </p14:sldIdLst>
         </p14:section>
-        <p14:section name="Wrap up" id="{e526bee0-af74-3d04-4022-001f4fcf2a94}">
+        <p14:section name="Wrap up" id="{173a7afc-c509-f391-9af6-509c519f2671}">
           <p14:sldIdLst>
             <p14:sldId id="284"/>
           </p14:sldIdLst>
@@ -4287,7 +4287,7 @@
               <a:t>After a few seconds a </a:t>
             </a:r>
             <a:r>
-              <a:rPr lang="en-US" sz="1500" dirty="0">
+              <a:rPr lang="en-US" sz="1500" b="1" dirty="0">
                 <a:solidFill>
                   <a:srgbClr val="B86E1E"/>
                 </a:solidFill>
@@ -4365,7 +4365,7 @@
               <a:t>. The prompt starts with </a:t>
             </a:r>
             <a:r>
-              <a:rPr lang="en-US" sz="1500" dirty="0">
+              <a:rPr lang="en-US" sz="1500" b="1" dirty="0">
                 <a:solidFill>
                   <a:srgbClr val="B86E1E"/>
                 </a:solidFill>
@@ -4604,7 +4604,7 @@
               <a:t>If the prompt doesn't start with </a:t>
             </a:r>
             <a:r>
-              <a:rPr lang="en-US" sz="1800" dirty="0">
+              <a:rPr lang="en-US" sz="1800" b="1" dirty="0">
                 <a:solidFill>
                   <a:srgbClr val="B86E1E"/>
                 </a:solidFill>
@@ -4623,7 +4623,7 @@
               <a:t>, close the terminal with the bin icon and open a new one. Libraries installed without </a:t>
             </a:r>
             <a:r>
-              <a:rPr lang="en-US" sz="1800" dirty="0">
+              <a:rPr lang="en-US" sz="1800" b="1" dirty="0">
                 <a:solidFill>
                   <a:srgbClr val="B86E1E"/>
                 </a:solidFill>
@@ -4923,7 +4923,7 @@
               <a:t> On some Windows computers, the new terminal shows this error instead of the </a:t>
             </a:r>
             <a:r>
-              <a:rPr lang="en-US" sz="1300" dirty="0">
+              <a:rPr lang="en-US" sz="1300" b="1" dirty="0">
                 <a:solidFill>
                   <a:srgbClr val="B86E1E"/>
                 </a:solidFill>
@@ -4960,7 +4960,7 @@
               <a:t>​</a:t>
             </a:r>
             <a:r>
-              <a:rPr lang="en-US" sz="1300" dirty="0">
+              <a:rPr lang="en-US" sz="1300" b="1" dirty="0">
                 <a:solidFill>
                   <a:srgbClr val="B86E1E"/>
                 </a:solidFill>
@@ -5333,7 +5333,7 @@
               <a:t>The prompt starts with </a:t>
             </a:r>
             <a:r>
-              <a:rPr lang="en-US" sz="1500" dirty="0">
+              <a:rPr lang="en-US" sz="1500" b="1" dirty="0">
                 <a:solidFill>
                   <a:srgbClr val="B86E1E"/>
                 </a:solidFill>
@@ -5352,7 +5352,7 @@
               <a:t> and ends with our folder's path and a </a:t>
             </a:r>
             <a:r>
-              <a:rPr lang="en-US" sz="1500" dirty="0">
+              <a:rPr lang="en-US" sz="1500" b="1" dirty="0">
                 <a:solidFill>
                   <a:srgbClr val="B86E1E"/>
                 </a:solidFill>
@@ -6494,7 +6494,7 @@
               <a:t>The </a:t>
             </a:r>
             <a:r>
-              <a:rPr lang="en-US" sz="1800" dirty="0">
+              <a:rPr lang="en-US" sz="1800" b="1" dirty="0">
                 <a:solidFill>
                   <a:srgbClr val="B86E1E"/>
                 </a:solidFill>
@@ -6700,7 +6700,7 @@
               <a:t>Our notebooks will look for the data in a folder called </a:t>
             </a:r>
             <a:r>
-              <a:rPr lang="en-US" sz="1600" dirty="0">
+              <a:rPr lang="en-US" sz="1600" b="1" dirty="0">
                 <a:solidFill>
                   <a:srgbClr val="E8A55A"/>
                 </a:solidFill>
@@ -7203,12 +7203,28 @@
               <a:t>In the Explorer panel, hover over </a:t>
             </a:r>
             <a:r>
+              <a:rPr lang="en-US" sz="1700" b="1" i="1" dirty="0">
+                <a:solidFill>
+                  <a:srgbClr val="2B1D19"/>
+                </a:solidFill>
+              </a:rPr>
+              <a:t>steam_data_stories</a:t>
+            </a:r>
+            <a:r>
+              <a:rPr lang="en-US" sz="1700" dirty="0">
+                <a:solidFill>
+                  <a:srgbClr val="2B1D19"/>
+                </a:solidFill>
+              </a:rPr>
+              <a:t>, click </a:t>
+            </a:r>
+            <a:r>
               <a:rPr lang="en-US" sz="1700" b="1" dirty="0">
                 <a:solidFill>
                   <a:srgbClr val="2B1D19"/>
                 </a:solidFill>
               </a:rPr>
-              <a:t>STEAM_DATA_STORIES</a:t>
+              <a:t>New Folder</a:t>
             </a:r>
             <a:r>
               <a:rPr lang="en-US" sz="1700" dirty="0">
@@ -7216,26 +7232,10 @@
                   <a:srgbClr val="2B1D19"/>
                 </a:solidFill>
               </a:rPr>
-              <a:t>, click </a:t>
-            </a:r>
-            <a:r>
-              <a:rPr lang="en-US" sz="1700" b="1" dirty="0">
-                <a:solidFill>
-                  <a:srgbClr val="2B1D19"/>
-                </a:solidFill>
-              </a:rPr>
-              <a:t>New Folder</a:t>
-            </a:r>
-            <a:r>
-              <a:rPr lang="en-US" sz="1700" dirty="0">
-                <a:solidFill>
-                  <a:srgbClr val="2B1D19"/>
-                </a:solidFill>
-              </a:rPr>
               <a:t> and name it </a:t>
             </a:r>
             <a:r>
-              <a:rPr lang="en-US" sz="1500" dirty="0">
+              <a:rPr lang="en-US" sz="1500" b="1" dirty="0">
                 <a:solidFill>
                   <a:srgbClr val="B86E1E"/>
                 </a:solidFill>
@@ -7281,7 +7281,7 @@
               <a:t>Download </a:t>
             </a:r>
             <a:r>
-              <a:rPr lang="en-US" sz="1500" dirty="0">
+              <a:rPr lang="en-US" sz="1500" b="1" dirty="0">
                 <a:solidFill>
                   <a:srgbClr val="B86E1E"/>
                 </a:solidFill>
@@ -7300,7 +7300,7 @@
               <a:t> and </a:t>
             </a:r>
             <a:r>
-              <a:rPr lang="en-US" sz="1500" dirty="0">
+              <a:rPr lang="en-US" sz="1500" b="1" dirty="0">
                 <a:solidFill>
                   <a:srgbClr val="B86E1E"/>
                 </a:solidFill>
@@ -7389,7 +7389,7 @@
               <a:t>Drag both files onto the </a:t>
             </a:r>
             <a:r>
-              <a:rPr lang="en-US" sz="1500" dirty="0">
+              <a:rPr lang="en-US" sz="1500" b="1" dirty="0">
                 <a:solidFill>
                   <a:srgbClr val="B86E1E"/>
                 </a:solidFill>
@@ -7644,7 +7644,7 @@
               <a:t>If we download a file more than once, the browser may rename it, such as </a:t>
             </a:r>
             <a:r>
-              <a:rPr lang="en-US" sz="1800" dirty="0">
+              <a:rPr lang="en-US" sz="1800" b="1" dirty="0">
                 <a:solidFill>
                   <a:srgbClr val="B86E1E"/>
                 </a:solidFill>
@@ -7663,7 +7663,7 @@
               <a:t>. Our code looks for </a:t>
             </a:r>
             <a:r>
-              <a:rPr lang="en-US" sz="1800" dirty="0">
+              <a:rPr lang="en-US" sz="1800" b="1" dirty="0">
                 <a:solidFill>
                   <a:srgbClr val="B86E1E"/>
                 </a:solidFill>
@@ -8115,7 +8115,7 @@
               <a:t>Check the Explorer panel matches this. Both data files must be inside </a:t>
             </a:r>
             <a:r>
-              <a:rPr lang="en-US" sz="1300" dirty="0">
+              <a:rPr lang="en-US" sz="1300" b="1" dirty="0">
                 <a:solidFill>
                   <a:srgbClr val="B86E1E"/>
                 </a:solidFill>
@@ -8346,7 +8346,7 @@
               <a:t>​</a:t>
             </a:r>
             <a:r>
-              <a:rPr lang="en-US" sz="1800" dirty="0">
+              <a:rPr lang="en-US" sz="1800" b="1" dirty="0">
                 <a:solidFill>
                   <a:srgbClr val="B86E1E"/>
                 </a:solidFill>
@@ -8512,7 +8512,7 @@
               <a:t>​</a:t>
             </a:r>
             <a:r>
-              <a:rPr lang="en-US" sz="1600" dirty="0">
+              <a:rPr lang="en-US" sz="1600" b="1" dirty="0">
                 <a:solidFill>
                   <a:srgbClr val="E8A55A"/>
                 </a:solidFill>
@@ -8905,7 +8905,7 @@
               <a:t>This starts marimo and creates a new notebook called </a:t>
             </a:r>
             <a:r>
-              <a:rPr lang="en-US" sz="1300" dirty="0">
+              <a:rPr lang="en-US" sz="1300" b="1" dirty="0">
                 <a:solidFill>
                   <a:srgbClr val="B86E1E"/>
                 </a:solidFill>
@@ -9103,7 +9103,7 @@
               <a:t>A new, empty marimo notebook called </a:t>
             </a:r>
             <a:r>
-              <a:rPr lang="en-US" sz="1100" i="1" dirty="0">
+              <a:rPr lang="en-US" sz="1100" b="1" i="1" dirty="0">
                 <a:solidFill>
                   <a:srgbClr val="B86E1E"/>
                 </a:solidFill>
@@ -9383,7 +9383,7 @@
               <a:t>Type </a:t>
             </a:r>
             <a:r>
-              <a:rPr lang="en-US" sz="1500" dirty="0">
+              <a:rPr lang="en-US" sz="1500" b="1" dirty="0">
                 <a:solidFill>
                   <a:srgbClr val="B86E1E"/>
                 </a:solidFill>
@@ -9445,7 +9445,7 @@
               <a:t>The terminal shows the </a:t>
             </a:r>
             <a:r>
-              <a:rPr lang="en-US" sz="1500" dirty="0">
+              <a:rPr lang="en-US" sz="1500" b="1" dirty="0">
                 <a:solidFill>
                   <a:srgbClr val="B86E1E"/>
                 </a:solidFill>
@@ -9795,7 +9795,7 @@
               <a:t>Our code is saved in </a:t>
             </a:r>
             <a:r>
-              <a:rPr lang="en-US" sz="1800" dirty="0">
+              <a:rPr lang="en-US" sz="1800" b="1" dirty="0">
                 <a:solidFill>
                   <a:srgbClr val="B86E1E"/>
                 </a:solidFill>
@@ -11284,7 +11284,7 @@
               <a:t>open the </a:t>
             </a:r>
             <a:r>
-              <a:rPr lang="en-US" sz="1300" dirty="0">
+              <a:rPr lang="en-US" sz="1300" b="1" dirty="0">
                 <a:solidFill>
                   <a:srgbClr val="B86E1E"/>
                 </a:solidFill>
@@ -12053,7 +12053,7 @@
               <a:t>Create a folder called </a:t>
             </a:r>
             <a:r>
-              <a:rPr lang="en-US" sz="1500" dirty="0">
+              <a:rPr lang="en-US" sz="1500" b="1" dirty="0">
                 <a:solidFill>
                   <a:srgbClr val="B86E1E"/>
                 </a:solidFill>
@@ -12217,12 +12217,12 @@
               <a:t>The Explorer panel now shows </a:t>
             </a:r>
             <a:r>
-              <a:rPr lang="en-US" sz="1700" b="1" dirty="0">
-                <a:solidFill>
-                  <a:srgbClr val="2B1D19"/>
-                </a:solidFill>
-              </a:rPr>
-              <a:t>STEAM_DATA_STORIES</a:t>
+              <a:rPr lang="en-US" sz="1700" b="1" i="1" dirty="0">
+                <a:solidFill>
+                  <a:srgbClr val="2B1D19"/>
+                </a:solidFill>
+              </a:rPr>
+              <a:t>steam_data_stories</a:t>
             </a:r>
             <a:r>
               <a:rPr lang="en-US" sz="1700" dirty="0">

</xml_diff>